<commit_message>
Add Partner Mode pack and partner line; save deck build scripts
- New Partner Mode pack (14 slides): a hosted tasting at a single
  vineyard, bar, restaurant, retailer or wine club, written to the host.
- Partner line "Conversation creates connection. Connection creates
  insight." on both partner packs; Event Mode brand and trust slides now
  shared with Partner Mode.
- Brand Brain (PROPOSED): Partner Mode definition, quizzes as learning,
  guest notes belong to guests, partner line for partner materials.
- Deck build scripts saved in decks/source.

Co-Authored-By: Claude Opus 5.5 <noreply@anthropic.com>
Claude-Session: https://claude.ai/code/session_012JYWa7EuArd2TznyfiWkZR
</commit_message>
<xml_diff>
--- a/decks/Entre Amis - Event Mode pack - DRAFT.pptx
+++ b/decks/Entre Amis - Event Mode pack - DRAFT.pptx
@@ -121,13 +121,13 @@
   <p:extLst>
     <p:ext uri="{521415D9-36F7-43E2-AB2F-B90AF26B5E84}">
       <p14:sectionLst xmlns:p14="http://schemas.microsoft.com/office/powerpoint/2010/main">
-        <p14:section name="Introduction" id="{46cc0697-0e51-d675-a9d0-1e4d9deca65f}">
+        <p14:section name="Introduction" id="{dabf1cf6-656a-b387-1a93-0d3193cf2db7}">
           <p14:sldIdLst>
             <p14:sldId id="256"/>
             <p14:sldId id="257"/>
           </p14:sldIdLst>
         </p14:section>
-        <p14:section name="Event Mode" id="{ca67fd7e-22e2-a15c-872d-56c97c85cf14}">
+        <p14:section name="Event Mode" id="{51542ecd-75dd-8ec8-5d6c-2481aa2ccff2}">
           <p14:sldIdLst>
             <p14:sldId id="258"/>
             <p14:sldId id="259"/>
@@ -137,21 +137,21 @@
             <p14:sldId id="263"/>
           </p14:sldIdLst>
         </p14:section>
-        <p14:section name="Working together" id="{0af013f5-d6bc-e853-3f9a-ed154621ee08}">
+        <p14:section name="Working together" id="{b7689625-2554-4810-41e5-6f360888f873}">
           <p14:sldIdLst>
             <p14:sldId id="264"/>
             <p14:sldId id="265"/>
             <p14:sldId id="266"/>
           </p14:sldIdLst>
         </p14:section>
-        <p14:section name="About us" id="{ec7c7bf8-d1ff-97de-e2f1-7e5d43783ca3}">
+        <p14:section name="About us" id="{1af4a4a9-01ab-4c34-2fb6-af3ace785686}">
           <p14:sldIdLst>
             <p14:sldId id="267"/>
             <p14:sldId id="268"/>
             <p14:sldId id="269"/>
           </p14:sldIdLst>
         </p14:section>
-        <p14:section name="Working notes — delete before sharing" id="{5fe85ec4-f169-ec1a-8239-fff1bb542b94}">
+        <p14:section name="Working notes — delete before sharing" id="{8ddf4c9a-b89d-9cac-ab3d-ab3c26de784e}">
           <p14:sldIdLst>
             <p14:sldId id="270"/>
           </p14:sldIdLst>
@@ -1176,7 +1176,7 @@
           <a:p>
             <a:r>
               <a:rPr lang="en-US" dirty="0"/>
-              <a:t>Made explicit that this is the brand, before the pack turns to Event Mode. Every line uses confirmed content apart from the third card's 'an honest view of what people think', drawn from the Partner Mode data rule ('helps partners understand what people genuinely think').</a:t>
+              <a:t>Makes it explicit that this is the brand. The closing line is the partner line (founder, 12 October): for Partner Mode and Event Mode materials only, not a consumer line.</a:t>
             </a:r>
             <a:endParaRPr lang="en-US" dirty="0"/>
           </a:p>
@@ -1704,7 +1704,7 @@
           <a:p>
             <a:r>
               <a:rPr lang="en-US" dirty="0"/>
-              <a:t>New slide built from the confirmed Partner Mode data rules ('That trust is the brand — Say what you really think only works if people are safe to do so') and the promises from 'Three layers of insight'. It answers the organiser's likely first question about data.</a:t>
+              <a:t>Built from the confirmed Partner Mode data rules ('That trust is the brand — Say what you really think only works if people are safe to do so') and the promises from the October deck's 'Three layers of insight'.</a:t>
             </a:r>
             <a:endParaRPr lang="en-US" dirty="0"/>
           </a:p>
@@ -2603,7 +2603,7 @@
                   <a:schemeClr val="tx1"/>
                 </a:solidFill>
               </a:rPr>
-              <a:t>What your visitors really think, and what it tells you.</a:t>
+              <a:t>Conversation creates connection. Connection creates insight.</a:t>
             </a:r>
             <a:endParaRPr lang="en-US" sz="1600" dirty="0"/>
           </a:p>
@@ -2659,7 +2659,7 @@
                   <a:schemeClr val="tx1"/>
                 </a:solidFill>
               </a:rPr>
-              <a:t>Event Mode is proposed in the Brand Brain. Its stage, and how it differs from Partner Mode, are still to decide. The italic line is new descriptive copy: keep or change.</a:t>
+              <a:t>Event Mode is proposed in the Brand Brain. Its stage, and how it differs from Partner Mode, are still to decide. The partner line is proposed too.</a:t>
             </a:r>
             <a:endParaRPr lang="en-US" sz="1100" dirty="0"/>
           </a:p>
@@ -5658,25 +5658,7 @@
                   <a:schemeClr val="tx1"/>
                 </a:solidFill>
               </a:rPr>
-              <a:t>Cover line (slide 1)</a:t>
-            </a:r>
-            <a:endParaRPr lang="en-US" sz="1400" dirty="0"/>
-          </a:p>
-          <a:p>
-            <a:pPr marL="203200" indent="-203200">
-              <a:spcAft>
-                <a:spcPts val="600"/>
-              </a:spcAft>
-              <a:buSzPct val="100000"/>
-              <a:buChar char="•"/>
-            </a:pPr>
-            <a:r>
-              <a:rPr lang="en-US" sz="1400" dirty="0">
-                <a:solidFill>
-                  <a:schemeClr val="tx1"/>
-                </a:solidFill>
-              </a:rPr>
-              <a:t>Conversations as a source of learning and connection (slide 2)</a:t>
+              <a:t>Partner line (slides 1, 2)</a:t>
             </a:r>
             <a:endParaRPr lang="en-US" sz="1400" dirty="0"/>
           </a:p>
@@ -6137,11 +6119,11 @@
         <p:spPr>
           <a:xfrm>
             <a:off x="548640" y="1783080"/>
-            <a:ext cx="11094415" cy="1097280"/>
+            <a:ext cx="11094415" cy="960120"/>
           </a:xfrm>
           <a:prstGeom prst="roundRect">
             <a:avLst>
-              <a:gd name="adj" fmla="val 10000"/>
+              <a:gd name="adj" fmla="val 11429"/>
             </a:avLst>
           </a:prstGeom>
           <a:solidFill>
@@ -6164,7 +6146,7 @@
         <p:spPr>
           <a:xfrm>
             <a:off x="1005840" y="1783080"/>
-            <a:ext cx="10180015" cy="1097280"/>
+            <a:ext cx="10180015" cy="960120"/>
           </a:xfrm>
           <a:prstGeom prst="rect">
             <a:avLst/>
@@ -6202,12 +6184,12 @@
         </p:nvSpPr>
         <p:spPr>
           <a:xfrm>
-            <a:off x="548640" y="3108960"/>
-            <a:ext cx="3515258" cy="1874520"/>
+            <a:off x="548640" y="2926080"/>
+            <a:ext cx="3515258" cy="1691640"/>
           </a:xfrm>
           <a:prstGeom prst="roundRect">
             <a:avLst>
-              <a:gd name="adj" fmla="val 5854"/>
+              <a:gd name="adj" fmla="val 6486"/>
             </a:avLst>
           </a:prstGeom>
           <a:solidFill>
@@ -6236,8 +6218,8 @@
         </p:nvSpPr>
         <p:spPr>
           <a:xfrm>
-            <a:off x="777240" y="3337560"/>
-            <a:ext cx="3058058" cy="1508760"/>
+            <a:off x="777240" y="3154680"/>
+            <a:ext cx="3058058" cy="1325880"/>
           </a:xfrm>
           <a:prstGeom prst="rect">
             <a:avLst/>
@@ -6312,12 +6294,12 @@
         </p:nvSpPr>
         <p:spPr>
           <a:xfrm>
-            <a:off x="4338218" y="3108960"/>
-            <a:ext cx="3515258" cy="1874520"/>
+            <a:off x="4338218" y="2926080"/>
+            <a:ext cx="3515258" cy="1691640"/>
           </a:xfrm>
           <a:prstGeom prst="roundRect">
             <a:avLst>
-              <a:gd name="adj" fmla="val 5854"/>
+              <a:gd name="adj" fmla="val 6486"/>
             </a:avLst>
           </a:prstGeom>
           <a:solidFill>
@@ -6346,8 +6328,8 @@
         </p:nvSpPr>
         <p:spPr>
           <a:xfrm>
-            <a:off x="4566818" y="3337560"/>
-            <a:ext cx="3058058" cy="1508760"/>
+            <a:off x="4566818" y="3154680"/>
+            <a:ext cx="3058058" cy="1325880"/>
           </a:xfrm>
           <a:prstGeom prst="rect">
             <a:avLst/>
@@ -6422,12 +6404,12 @@
         </p:nvSpPr>
         <p:spPr>
           <a:xfrm>
-            <a:off x="8127797" y="3108960"/>
-            <a:ext cx="3515258" cy="1874520"/>
+            <a:off x="8127797" y="2926080"/>
+            <a:ext cx="3515258" cy="1691640"/>
           </a:xfrm>
           <a:prstGeom prst="roundRect">
             <a:avLst>
-              <a:gd name="adj" fmla="val 5854"/>
+              <a:gd name="adj" fmla="val 6486"/>
             </a:avLst>
           </a:prstGeom>
           <a:solidFill>
@@ -6456,8 +6438,8 @@
         </p:nvSpPr>
         <p:spPr>
           <a:xfrm>
-            <a:off x="8356397" y="3337560"/>
-            <a:ext cx="3058058" cy="1508760"/>
+            <a:off x="8356397" y="3154680"/>
+            <a:ext cx="3058058" cy="1325880"/>
           </a:xfrm>
           <a:prstGeom prst="rect">
             <a:avLst/>
@@ -6518,7 +6500,7 @@
                   <a:schemeClr val="tx1"/>
                 </a:solidFill>
               </a:rPr>
-              <a:t>What we add isn't content. It's connection, and an honest view of what people think.</a:t>
+              <a:t>What we add isn't content. It's connection.</a:t>
             </a:r>
             <a:endParaRPr lang="en-US" sz="1500" dirty="0"/>
           </a:p>
@@ -6526,14 +6508,53 @@
       </p:sp>
       <p:sp>
         <p:nvSpPr>
-          <p:cNvPr id="12" name="FLAG — delete before sharing"/>
+          <p:cNvPr id="12" name="Text 10"/>
           <p:cNvSpPr txBox="1"/>
           <p:nvPr/>
         </p:nvSpPr>
         <p:spPr>
           <a:xfrm>
-            <a:off x="548640" y="5212080"/>
-            <a:ext cx="11094415" cy="731520"/>
+            <a:off x="548640" y="4800600"/>
+            <a:ext cx="11094415" cy="548640"/>
+          </a:xfrm>
+          <a:prstGeom prst="rect">
+            <a:avLst/>
+          </a:prstGeom>
+          <a:noFill/>
+          <a:ln/>
+        </p:spPr>
+        <p:txBody>
+          <a:bodyPr wrap="square" lIns="0" tIns="0" rIns="0" bIns="0" rtlCol="0" anchor="t"/>
+          <a:lstStyle/>
+          <a:p>
+            <a:pPr algn="ctr" indent="0" marL="0">
+              <a:spcAft>
+                <a:spcPts val="400"/>
+              </a:spcAft>
+              <a:buNone/>
+            </a:pPr>
+            <a:r>
+              <a:rPr lang="en-US" sz="2600" dirty="0">
+                <a:solidFill>
+                  <a:schemeClr val="tx1"/>
+                </a:solidFill>
+              </a:rPr>
+              <a:t>Conversation creates connection. Connection creates insight.</a:t>
+            </a:r>
+            <a:endParaRPr lang="en-US" sz="2600" dirty="0"/>
+          </a:p>
+        </p:txBody>
+      </p:sp>
+      <p:sp>
+        <p:nvSpPr>
+          <p:cNvPr id="13" name="FLAG — delete before sharing"/>
+          <p:cNvSpPr txBox="1"/>
+          <p:nvPr/>
+        </p:nvSpPr>
+        <p:spPr>
+          <a:xfrm>
+            <a:off x="3169768" y="5486400"/>
+            <a:ext cx="5852160" cy="457200"/>
           </a:xfrm>
           <a:prstGeom prst="rect">
             <a:avLst/>
@@ -6563,7 +6584,7 @@
                 <a:ea typeface="Raleway SemiBold" pitchFamily="34" charset="-122"/>
                 <a:cs typeface="Raleway SemiBold" pitchFamily="34" charset="-120"/>
               </a:rPr>
-              <a:t>TO DISCUSS  </a:t>
+              <a:t>TO CONFIRM  </a:t>
             </a:r>
             <a:pPr indent="0" marL="0">
               <a:buNone/>
@@ -6574,7 +6595,7 @@
                   <a:schemeClr val="tx1"/>
                 </a:solidFill>
               </a:rPr>
-              <a:t>Your new thought: conversations are a source of rich learning and connection. It could be the bridge from the brand to insight on this slide. Not used yet; let's work out the wording together.</a:t>
+              <a:t>Partner line, proposed in the Brand Brain.</a:t>
             </a:r>
             <a:endParaRPr lang="en-US" sz="1100" dirty="0"/>
           </a:p>
@@ -10919,7 +10940,7 @@
                   <a:schemeClr val="tx1"/>
                 </a:solidFill>
               </a:rPr>
-              <a:t>Opinions and tasting responses are combined and anonymised, never linked to a name.</a:t>
+              <a:t>Opinions and responses are combined and anonymised, never linked to a name.</a:t>
             </a:r>
             <a:endParaRPr lang="en-US" sz="1400" dirty="0"/>
           </a:p>
@@ -11099,7 +11120,7 @@
                   <a:schemeClr val="tx1"/>
                 </a:solidFill>
               </a:rPr>
-              <a:t>No public ranking of vineyards by default.</a:t>
+              <a:t>No public ranking of producers by default.</a:t>
             </a:r>
             <a:endParaRPr lang="en-US" sz="1400" dirty="0"/>
           </a:p>

</xml_diff>

<commit_message>
Separate Wine 101 (directory) from My wines (personal record)
Founder correction, 12 October: Wine 101 is wine facts and general help,
like a directory; My wines is the guest's personal record of tastings,
favourites, events and experiences. Recorded as PROPOSED alongside the
confirmed definition; which feature is built is flagged as TODO. Core
app slide and Event Mode visitor list updated.

Co-Authored-By: Claude Opus 5.5 <noreply@anthropic.com>
Claude-Session: https://claude.ai/code/session_012JYWa7EuArd2TznyfiWkZR
</commit_message>
<xml_diff>
--- a/decks/Entre Amis - Event Mode pack - DRAFT.pptx
+++ b/decks/Entre Amis - Event Mode pack - DRAFT.pptx
@@ -121,13 +121,13 @@
   <p:extLst>
     <p:ext uri="{521415D9-36F7-43E2-AB2F-B90AF26B5E84}">
       <p14:sectionLst xmlns:p14="http://schemas.microsoft.com/office/powerpoint/2010/main">
-        <p14:section name="Introduction" id="{dabf1cf6-656a-b387-1a93-0d3193cf2db7}">
+        <p14:section name="Introduction" id="{f8e8cf07-88b3-28a9-13c6-d4e70628f171}">
           <p14:sldIdLst>
             <p14:sldId id="256"/>
             <p14:sldId id="257"/>
           </p14:sldIdLst>
         </p14:section>
-        <p14:section name="Event Mode" id="{51542ecd-75dd-8ec8-5d6c-2481aa2ccff2}">
+        <p14:section name="Event Mode" id="{cb304ab3-7aaf-c928-8548-b125a49f58a1}">
           <p14:sldIdLst>
             <p14:sldId id="258"/>
             <p14:sldId id="259"/>
@@ -137,21 +137,21 @@
             <p14:sldId id="263"/>
           </p14:sldIdLst>
         </p14:section>
-        <p14:section name="Working together" id="{b7689625-2554-4810-41e5-6f360888f873}">
+        <p14:section name="Working together" id="{ad2a4529-9956-854f-0964-52ce9d6ef961}">
           <p14:sldIdLst>
             <p14:sldId id="264"/>
             <p14:sldId id="265"/>
             <p14:sldId id="266"/>
           </p14:sldIdLst>
         </p14:section>
-        <p14:section name="About us" id="{1af4a4a9-01ab-4c34-2fb6-af3ace785686}">
+        <p14:section name="About us" id="{419a1eb6-f295-1d93-6cfb-660d7f31e403}">
           <p14:sldIdLst>
             <p14:sldId id="267"/>
             <p14:sldId id="268"/>
             <p14:sldId id="269"/>
           </p14:sldIdLst>
         </p14:section>
-        <p14:section name="Working notes — delete before sharing" id="{8ddf4c9a-b89d-9cac-ab3d-ab3c26de784e}">
+        <p14:section name="Working notes — delete before sharing" id="{c7d549da-7f70-829f-9dfa-fd408d98808d}">
           <p14:sldIdLst>
             <p14:sldId id="270"/>
           </p14:sldIdLst>
@@ -7626,7 +7626,7 @@
                   <a:schemeClr val="tx1"/>
                 </a:solidFill>
               </a:rPr>
-              <a:t>A personal record to revisit after the event.</a:t>
+              <a:t>A personal record in My wines, to revisit after the event.</a:t>
             </a:r>
             <a:endParaRPr lang="en-US" sz="1600" dirty="0"/>
           </a:p>

</xml_diff>

<commit_message>
Confirm founder-approved Brand Brain proposals (founder approved)
Caroline approved, 12 October 2026: brand purpose, brand journey,
Partner Mode and Event Mode, Wine 101 and My wines, early thinking kept
internal, audiences (investors deferred), game line, partner materials
rules and partner line, partner vocabulary, unattributed observations.
Logged in CHANGELOG. The brand-wide consumer line is now TODO.

Still PROPOSED: contact details with consent (pending legal review) and
expression colours. Deck flags for confirmed items removed.

Co-Authored-By: Claude Opus 5.5 <noreply@anthropic.com>
Claude-Session: https://claude.ai/code/session_012JYWa7EuArd2TznyfiWkZR
</commit_message>
<xml_diff>
--- a/decks/Entre Amis - Event Mode pack - DRAFT.pptx
+++ b/decks/Entre Amis - Event Mode pack - DRAFT.pptx
@@ -121,13 +121,13 @@
   <p:extLst>
     <p:ext uri="{521415D9-36F7-43E2-AB2F-B90AF26B5E84}">
       <p14:sectionLst xmlns:p14="http://schemas.microsoft.com/office/powerpoint/2010/main">
-        <p14:section name="Introduction" id="{f8e8cf07-88b3-28a9-13c6-d4e70628f171}">
+        <p14:section name="Introduction" id="{c0ca1213-b9c0-e1e9-e25b-47b962abdabe}">
           <p14:sldIdLst>
             <p14:sldId id="256"/>
             <p14:sldId id="257"/>
           </p14:sldIdLst>
         </p14:section>
-        <p14:section name="Event Mode" id="{cb304ab3-7aaf-c928-8548-b125a49f58a1}">
+        <p14:section name="Event Mode" id="{b0363421-1762-394f-0876-ff6fe013c7c3}">
           <p14:sldIdLst>
             <p14:sldId id="258"/>
             <p14:sldId id="259"/>
@@ -137,21 +137,21 @@
             <p14:sldId id="263"/>
           </p14:sldIdLst>
         </p14:section>
-        <p14:section name="Working together" id="{ad2a4529-9956-854f-0964-52ce9d6ef961}">
+        <p14:section name="Working together" id="{cfe0f26d-bed1-731e-6689-28fefae79757}">
           <p14:sldIdLst>
             <p14:sldId id="264"/>
             <p14:sldId id="265"/>
             <p14:sldId id="266"/>
           </p14:sldIdLst>
         </p14:section>
-        <p14:section name="About us" id="{419a1eb6-f295-1d93-6cfb-660d7f31e403}">
+        <p14:section name="About us" id="{582e0b74-5563-cec0-ce7c-f6ee4173aba4}">
           <p14:sldIdLst>
             <p14:sldId id="267"/>
             <p14:sldId id="268"/>
             <p14:sldId id="269"/>
           </p14:sldIdLst>
         </p14:section>
-        <p14:section name="Working notes — delete before sharing" id="{c7d549da-7f70-829f-9dfa-fd408d98808d}">
+        <p14:section name="Working notes — delete before sharing" id="{8e1a17c0-b602-e647-8841-dc993688b06c}">
           <p14:sldIdLst>
             <p14:sldId id="270"/>
           </p14:sldIdLst>
@@ -2648,7 +2648,7 @@
                 <a:ea typeface="Raleway SemiBold" pitchFamily="34" charset="-122"/>
                 <a:cs typeface="Raleway SemiBold" pitchFamily="34" charset="-120"/>
               </a:rPr>
-              <a:t>TO CONFIRM  </a:t>
+              <a:t>TO DECIDE  </a:t>
             </a:r>
             <a:pPr indent="0" marL="0">
               <a:buNone/>
@@ -2659,7 +2659,7 @@
                   <a:schemeClr val="tx1"/>
                 </a:solidFill>
               </a:rPr>
-              <a:t>Event Mode is proposed in the Brand Brain. Its stage, and how it differs from Partner Mode, are still to decide. The partner line is proposed too.</a:t>
+              <a:t>Event Mode's stage, and its detailed differences from Partner Mode.</a:t>
             </a:r>
             <a:endParaRPr lang="en-US" sz="1100" dirty="0"/>
           </a:p>
@@ -5640,25 +5640,7 @@
                   <a:schemeClr val="tx1"/>
                 </a:solidFill>
               </a:rPr>
-              <a:t>Event Mode: confirm, set its stage and how it differs from Partner Mode</a:t>
-            </a:r>
-            <a:endParaRPr lang="en-US" sz="1400" dirty="0"/>
-          </a:p>
-          <a:p>
-            <a:pPr marL="203200" indent="-203200">
-              <a:spcAft>
-                <a:spcPts val="600"/>
-              </a:spcAft>
-              <a:buSzPct val="100000"/>
-              <a:buChar char="•"/>
-            </a:pPr>
-            <a:r>
-              <a:rPr lang="en-US" sz="1400" dirty="0">
-                <a:solidFill>
-                  <a:schemeClr val="tx1"/>
-                </a:solidFill>
-              </a:rPr>
-              <a:t>Partner line (slides 1, 2)</a:t>
+              <a:t>Event Mode: its stage and how it differs from Partner Mode</a:t>
             </a:r>
             <a:endParaRPr lang="en-US" sz="1400" dirty="0"/>
           </a:p>
@@ -6542,62 +6524,6 @@
               <a:t>Conversation creates connection. Connection creates insight.</a:t>
             </a:r>
             <a:endParaRPr lang="en-US" sz="2600" dirty="0"/>
-          </a:p>
-        </p:txBody>
-      </p:sp>
-      <p:sp>
-        <p:nvSpPr>
-          <p:cNvPr id="13" name="FLAG — delete before sharing"/>
-          <p:cNvSpPr txBox="1"/>
-          <p:nvPr/>
-        </p:nvSpPr>
-        <p:spPr>
-          <a:xfrm>
-            <a:off x="3169768" y="5486400"/>
-            <a:ext cx="5852160" cy="457200"/>
-          </a:xfrm>
-          <a:prstGeom prst="rect">
-            <a:avLst/>
-          </a:prstGeom>
-          <a:solidFill>
-            <a:schemeClr val="bg1"/>
-          </a:solidFill>
-          <a:ln w="25400">
-            <a:solidFill>
-              <a:schemeClr val="accent4"/>
-            </a:solidFill>
-          </a:ln>
-        </p:spPr>
-        <p:txBody>
-          <a:bodyPr wrap="square" lIns="38100" tIns="76200" rIns="76200" bIns="38100" rtlCol="0" anchor="ctr"/>
-          <a:lstStyle/>
-          <a:p>
-            <a:pPr indent="0" marL="0">
-              <a:buNone/>
-            </a:pPr>
-            <a:r>
-              <a:rPr lang="en-US" sz="1100" dirty="0">
-                <a:solidFill>
-                  <a:schemeClr val="tx1"/>
-                </a:solidFill>
-                <a:latin typeface="Raleway SemiBold" pitchFamily="34" charset="0"/>
-                <a:ea typeface="Raleway SemiBold" pitchFamily="34" charset="-122"/>
-                <a:cs typeface="Raleway SemiBold" pitchFamily="34" charset="-120"/>
-              </a:rPr>
-              <a:t>TO CONFIRM  </a:t>
-            </a:r>
-            <a:pPr indent="0" marL="0">
-              <a:buNone/>
-            </a:pPr>
-            <a:r>
-              <a:rPr lang="en-US" sz="1100" dirty="0">
-                <a:solidFill>
-                  <a:schemeClr val="tx1"/>
-                </a:solidFill>
-              </a:rPr>
-              <a:t>Partner line, proposed in the Brand Brain.</a:t>
-            </a:r>
-            <a:endParaRPr lang="en-US" sz="1100" dirty="0"/>
           </a:p>
         </p:txBody>
       </p:sp>

</xml_diff>

<commit_message>
Decks: core brand story and Event Mode pack follow the confirmed feature status (16 Oct 2026)
Core: app slide adds label photo, My wines on any device, questions about the
wine in the glass, Just tasting; Event Mode stage flags removed.
Event: stage flags removed; differences from Partner Mode still to decide.

Co-Authored-By: Claude Opus 5.5 <noreply@anthropic.com>
Claude-Session: https://claude.ai/code/session_01CovfkoPR3muazrwRLaF3Xr
</commit_message>
<xml_diff>
--- a/decks/Entre Amis - Event Mode pack - DRAFT.pptx
+++ b/decks/Entre Amis - Event Mode pack - DRAFT.pptx
@@ -122,13 +122,13 @@
   <p:extLst>
     <p:ext uri="{521415D9-36F7-43E2-AB2F-B90AF26B5E84}">
       <p14:sectionLst xmlns:p14="http://schemas.microsoft.com/office/powerpoint/2010/main">
-        <p14:section name="Introduction" id="{231fa06a-da83-813b-1cc3-4700338607b8}">
+        <p14:section name="Introduction" id="{38a1325b-fa65-05b1-da29-3985533423f3}">
           <p14:sldIdLst>
             <p14:sldId id="256"/>
             <p14:sldId id="257"/>
           </p14:sldIdLst>
         </p14:section>
-        <p14:section name="Event Mode" id="{3fd6c50b-7362-1760-63cd-bb1354b68a6a}">
+        <p14:section name="Event Mode" id="{7ad6dd89-8f95-a226-3212-39341f44cc17}">
           <p14:sldIdLst>
             <p14:sldId id="258"/>
             <p14:sldId id="259"/>
@@ -139,21 +139,21 @@
             <p14:sldId id="264"/>
           </p14:sldIdLst>
         </p14:section>
-        <p14:section name="Working together" id="{fd52be1b-a8ac-77b1-d5e5-1d0e6a20daf2}">
+        <p14:section name="Working together" id="{9d2c15b2-d6fd-5bb5-ea73-b29c2c9947cd}">
           <p14:sldIdLst>
             <p14:sldId id="265"/>
             <p14:sldId id="266"/>
             <p14:sldId id="267"/>
           </p14:sldIdLst>
         </p14:section>
-        <p14:section name="About us" id="{8a5df74b-f990-643c-8a1c-1e2cbe147219}">
+        <p14:section name="About us" id="{4580eee1-6252-6400-2aa9-440bf9e97a85}">
           <p14:sldIdLst>
             <p14:sldId id="268"/>
             <p14:sldId id="269"/>
             <p14:sldId id="270"/>
           </p14:sldIdLst>
         </p14:section>
-        <p14:section name="Working notes — delete before sharing" id="{19b45441-f726-735b-ac80-03e11f0fd809}">
+        <p14:section name="Working notes — delete before sharing" id="{67b20c2b-1bf4-4b06-cf76-b696ef123b07}">
           <p14:sldIdLst>
             <p14:sldId id="271"/>
           </p14:sldIdLst>
@@ -1442,7 +1442,7 @@
           <a:p>
             <a:r>
               <a:rPr lang="en-US" dirty="0"/>
-              <a:t>New spine for the pack, as you suggested. Visitor side from the October 'During / Personal / After' slide. Quizzes and prizes left off until decided: quizzes need to fit 'no wrong answers', and prizes near alcohol need checking against CAP and Portman Group rules. 'Save wines in seconds' isn't used: it's a speed claim and suggests wine recognition, which isn't claimable yet.</a:t>
+              <a:t>New spine for the pack, as you suggested. Visitor side from the October 'During / Personal / After' slide. Quizzes and prizes left off until decided: quizzes need to fit 'no wrong answers', and prizes near alcohol need checking against CAP and Portman Group rules. 'Save wines in seconds' isn't used: it's a speed claim.</a:t>
             </a:r>
             <a:endParaRPr lang="en-US" dirty="0"/>
           </a:p>
@@ -1794,7 +1794,7 @@
           <a:p>
             <a:r>
               <a:rPr lang="en-US" dirty="0"/>
-              <a:t>New slide, 16 October: the benefits for wine businesses, from the app as built to 15 October 2026 (Event Mode prototype: visitor and organiser screens, stand QR cards, one question per wine, crowning and prize draw). Producer totals are recorded but the screen that shows them is not built yet. Contacts follow the proposed Brand Brain rule: one tick box per producer, never pre-ticked, no opinions attached. Event Mode's stage is still to confirm, so this slide is draft-only.</a:t>
+              <a:t>New slide, 16 October: the benefits for wine businesses, from the app as built to 15 October 2026 (Event Mode prototype: visitor and organiser screens, stand QR cards, one question per wine, crowning and prize draw). Producer totals are recorded but the screen that shows them is not built yet. Contacts follow the proposed Brand Brain rule: one tick box per producer, never pre-ticked, no opinions attached. Event Mode may be described as in development (Brand Brain, 16 October); the prize draw, reports and contact details are not claimable yet, hence the flags.</a:t>
             </a:r>
             <a:endParaRPr lang="en-US" dirty="0"/>
           </a:p>
@@ -2749,7 +2749,7 @@
                   <a:schemeClr val="tx1"/>
                 </a:solidFill>
               </a:rPr>
-              <a:t>Event Mode's stage, and its detailed differences from Partner Mode.</a:t>
+              <a:t>Event Mode's detailed differences from Partner Mode.</a:t>
             </a:r>
             <a:endParaRPr lang="en-US" sz="1100" dirty="0"/>
           </a:p>
@@ -4580,7 +4580,7 @@
                   <a:schemeClr val="tx1"/>
                 </a:solidFill>
               </a:rPr>
-              <a:t>Where each is today (15 October): prototype built and working, with visitor and organiser screens and stand QR cards. Example report: totals recorded, report screen in progress. First pilot: planned. Event Mode's stage still to confirm.</a:t>
+              <a:t>Where each is today (15 October): prototype built and working, with visitor and organiser screens and stand QR cards. Example report: totals recorded, report screen in progress. First pilot: planned.</a:t>
             </a:r>
             <a:endParaRPr lang="en-US" sz="1100" dirty="0"/>
           </a:p>
@@ -6314,7 +6314,7 @@
                   <a:schemeClr val="tx1"/>
                 </a:solidFill>
               </a:rPr>
-              <a:t>Event Mode: its stage and how it differs from Partner Mode</a:t>
+              <a:t>Event Mode: how it differs from Partner Mode</a:t>
             </a:r>
             <a:endParaRPr lang="en-US" sz="1400" dirty="0"/>
           </a:p>

</xml_diff>